<commit_message>
reran Baseline/ 3-year comparison stats + data, generated plots
</commit_message>
<xml_diff>
--- a/presentations/plot.pptx
+++ b/presentations/plot.pptx
@@ -6,6 +6,7 @@
   </p:sldMasterIdLst>
   <p:sldIdLst>
     <p:sldId id="256" r:id="rId8"/>
+    <p:sldId id="257" r:id="rId9"/>
   </p:sldIdLst>
   <p:sldSz cx="9144000" cy="6858000" type="screen4x3"/>
   <p:notesSz cx="6858000" cy="9144000"/>
@@ -2198,6 +2199,84 @@
 </file>
 
 <file path=ppt/slides/slide1.xml><?xml version="1.0" encoding="utf-8"?>
+<p:sld xmlns:a="http://schemas.openxmlformats.org/drawingml/2006/main" xmlns:r="http://schemas.openxmlformats.org/officeDocument/2006/relationships" xmlns:p="http://schemas.openxmlformats.org/presentationml/2006/main">
+  <p:cSld>
+    <p:spTree>
+      <p:nvGrpSpPr>
+        <p:cNvPr id="1" name=""/>
+        <p:cNvGrpSpPr/>
+        <p:nvPr/>
+      </p:nvGrpSpPr>
+      <p:grpSpPr>
+        <a:xfrm>
+          <a:off x="0" y="0"/>
+          <a:ext cx="0" cy="0"/>
+          <a:chOff x="0" y="0"/>
+          <a:chExt cx="0" cy="0"/>
+        </a:xfrm>
+      </p:grpSpPr>
+      <p:pic>
+        <p:nvPicPr>
+          <p:cNvPr id="2" name="" descr=""/>
+          <p:cNvPicPr>
+            <a:picLocks noGrp="1"/>
+          </p:cNvPicPr>
+          <p:nvPr>
+            <p:ph/>
+          </p:nvPr>
+        </p:nvPicPr>
+        <p:blipFill>
+          <a:blip cstate="print" r:embed="rId2"/>
+          <a:stretch>
+            <a:fillRect/>
+          </a:stretch>
+        </p:blipFill>
+        <p:spPr>
+          <a:xfrm>
+            <a:off x="0" y="0"/>
+            <a:ext cx="9144000" cy="6858000"/>
+          </a:xfrm>
+          <a:prstGeom prst="rect">
+            <a:avLst/>
+          </a:prstGeom>
+        </p:spPr>
+      </p:pic>
+      <p:sp>
+        <p:nvSpPr>
+          <p:cNvPr id="3" name="Title 1"/>
+          <p:cNvSpPr>
+            <a:spLocks noGrp="1"/>
+          </p:cNvSpPr>
+          <p:nvPr>
+            <p:ph type="title"/>
+          </p:nvPr>
+        </p:nvSpPr>
+        <p:spPr>
+          <a:xfrm>
+            <a:off x="457200" y="274638"/>
+            <a:ext cx="8229600" cy="1143000"/>
+          </a:xfrm>
+        </p:spPr>
+        <p:txBody>
+          <a:bodyPr/>
+          <a:lstStyle/>
+          <a:p>
+            <a:r>
+              <a:rPr/>
+              <a:t>Plot</a:t>
+            </a:r>
+          </a:p>
+        </p:txBody>
+      </p:sp>
+    </p:spTree>
+  </p:cSld>
+  <p:clrMapOvr>
+    <a:masterClrMapping/>
+  </p:clrMapOvr>
+</p:sld>
+</file>
+
+<file path=ppt/slides/slide2.xml><?xml version="1.0" encoding="utf-8"?>
 <p:sld xmlns:a="http://schemas.openxmlformats.org/drawingml/2006/main" xmlns:r="http://schemas.openxmlformats.org/officeDocument/2006/relationships" xmlns:p="http://schemas.openxmlformats.org/presentationml/2006/main">
   <p:cSld>
     <p:spTree>

</xml_diff>

<commit_message>
analyzed and generated figures for all OsHV-1 figures!
</commit_message>
<xml_diff>
--- a/presentations/plot.pptx
+++ b/presentations/plot.pptx
@@ -6,7 +6,6 @@
   </p:sldMasterIdLst>
   <p:sldIdLst>
     <p:sldId id="256" r:id="rId8"/>
-    <p:sldId id="257" r:id="rId9"/>
   </p:sldIdLst>
   <p:sldSz cx="9144000" cy="6858000" type="screen4x3"/>
   <p:notesSz cx="6858000" cy="9144000"/>
@@ -2199,84 +2198,6 @@
 </file>
 
 <file path=ppt/slides/slide1.xml><?xml version="1.0" encoding="utf-8"?>
-<p:sld xmlns:a="http://schemas.openxmlformats.org/drawingml/2006/main" xmlns:r="http://schemas.openxmlformats.org/officeDocument/2006/relationships" xmlns:p="http://schemas.openxmlformats.org/presentationml/2006/main">
-  <p:cSld>
-    <p:spTree>
-      <p:nvGrpSpPr>
-        <p:cNvPr id="1" name=""/>
-        <p:cNvGrpSpPr/>
-        <p:nvPr/>
-      </p:nvGrpSpPr>
-      <p:grpSpPr>
-        <a:xfrm>
-          <a:off x="0" y="0"/>
-          <a:ext cx="0" cy="0"/>
-          <a:chOff x="0" y="0"/>
-          <a:chExt cx="0" cy="0"/>
-        </a:xfrm>
-      </p:grpSpPr>
-      <p:pic>
-        <p:nvPicPr>
-          <p:cNvPr id="2" name="" descr=""/>
-          <p:cNvPicPr>
-            <a:picLocks noGrp="1"/>
-          </p:cNvPicPr>
-          <p:nvPr>
-            <p:ph/>
-          </p:nvPr>
-        </p:nvPicPr>
-        <p:blipFill>
-          <a:blip cstate="print" r:embed="rId2"/>
-          <a:stretch>
-            <a:fillRect/>
-          </a:stretch>
-        </p:blipFill>
-        <p:spPr>
-          <a:xfrm>
-            <a:off x="0" y="0"/>
-            <a:ext cx="9144000" cy="6858000"/>
-          </a:xfrm>
-          <a:prstGeom prst="rect">
-            <a:avLst/>
-          </a:prstGeom>
-        </p:spPr>
-      </p:pic>
-      <p:sp>
-        <p:nvSpPr>
-          <p:cNvPr id="3" name="Title 1"/>
-          <p:cNvSpPr>
-            <a:spLocks noGrp="1"/>
-          </p:cNvSpPr>
-          <p:nvPr>
-            <p:ph type="title"/>
-          </p:nvPr>
-        </p:nvSpPr>
-        <p:spPr>
-          <a:xfrm>
-            <a:off x="457200" y="274638"/>
-            <a:ext cx="8229600" cy="1143000"/>
-          </a:xfrm>
-        </p:spPr>
-        <p:txBody>
-          <a:bodyPr/>
-          <a:lstStyle/>
-          <a:p>
-            <a:r>
-              <a:rPr/>
-              <a:t>Plot</a:t>
-            </a:r>
-          </a:p>
-        </p:txBody>
-      </p:sp>
-    </p:spTree>
-  </p:cSld>
-  <p:clrMapOvr>
-    <a:masterClrMapping/>
-  </p:clrMapOvr>
-</p:sld>
-</file>
-
-<file path=ppt/slides/slide2.xml><?xml version="1.0" encoding="utf-8"?>
 <p:sld xmlns:a="http://schemas.openxmlformats.org/drawingml/2006/main" xmlns:r="http://schemas.openxmlformats.org/officeDocument/2006/relationships" xmlns:p="http://schemas.openxmlformats.org/presentationml/2006/main">
   <p:cSld>
     <p:spTree>

</xml_diff>